<commit_message>
Capture operator screenshots and training package v2
</commit_message>
<xml_diff>
--- a/docs/generated/mdms-preproduct-operator-training-draft.pptx
+++ b/docs/generated/mdms-preproduct-operator-training-draft.pptx
@@ -79,64 +79,64 @@
         <p:spPr>
           <a:xfrm>
             <a:off x="457200" y="1600200"/>
-            <a:ext cx="6858000" cy="4572000"/>
-          </a:xfrm>
-          <a:prstGeom prst="rect">
-            <a:avLst/>
-          </a:prstGeom>
-          <a:noFill/>
-          <a:ln>
-            <a:noFill/>
-          </a:ln>
-        </p:spPr>
-        <p:txBody>
-          <a:bodyPr wrap="square"/>
-          <a:lstStyle/>
-          <a:p>
-            <a:r>
-              <a:rPr lang="ko-KR" sz="1800"/>
+            <a:ext cx="3429000" cy="4572000"/>
+          </a:xfrm>
+          <a:prstGeom prst="rect">
+            <a:avLst/>
+          </a:prstGeom>
+          <a:noFill/>
+          <a:ln>
+            <a:noFill/>
+          </a:ln>
+        </p:spPr>
+        <p:txBody>
+          <a:bodyPr wrap="square"/>
+          <a:lstStyle/>
+          <a:p>
+            <a:r>
+              <a:rPr lang="ko-KR" sz="1700"/>
               <a:t>• title</a:t>
             </a:r>
             <a:endParaRPr lang="ko-KR"/>
           </a:p>
           <a:p>
             <a:r>
-              <a:rPr lang="ko-KR" sz="1800"/>
+              <a:rPr lang="ko-KR" sz="1700"/>
               <a:t>  - MDMS Preproduct Operator Manual</a:t>
             </a:r>
             <a:endParaRPr lang="ko-KR"/>
           </a:p>
           <a:p>
             <a:r>
-              <a:rPr lang="ko-KR" sz="1800"/>
+              <a:rPr lang="ko-KR" sz="1700"/>
               <a:t>• subtitle</a:t>
             </a:r>
             <a:endParaRPr lang="ko-KR"/>
           </a:p>
           <a:p>
             <a:r>
-              <a:rPr lang="ko-KR" sz="1800"/>
+              <a:rPr lang="ko-KR" sz="1700"/>
               <a:t>  - bounded internal-use operating guide</a:t>
             </a:r>
             <a:endParaRPr lang="ko-KR"/>
           </a:p>
           <a:p>
             <a:r>
-              <a:rPr lang="ko-KR" sz="1800"/>
+              <a:rPr lang="ko-KR" sz="1700"/>
               <a:t>• speaker focus</a:t>
             </a:r>
             <a:endParaRPr lang="ko-KR"/>
           </a:p>
           <a:p>
             <a:r>
-              <a:rPr lang="ko-KR" sz="1800"/>
+              <a:rPr lang="ko-KR" sz="1700"/>
               <a:t>  - what this system currently supports</a:t>
             </a:r>
             <a:endParaRPr lang="ko-KR"/>
           </a:p>
           <a:p>
             <a:r>
-              <a:rPr lang="ko-KR" sz="1800"/>
+              <a:rPr lang="ko-KR" sz="1700"/>
               <a:t>  - who should use admin versus operator</a:t>
             </a:r>
             <a:endParaRPr lang="ko-KR"/>
@@ -151,8 +151,8 @@
         </p:nvSpPr>
         <p:spPr>
           <a:xfrm>
-            <a:off x="7543800" y="1600200"/>
-            <a:ext cx="3200400" cy="4572000"/>
+            <a:off x="4343400" y="1600200"/>
+            <a:ext cx="7391400" cy="4572000"/>
           </a:xfrm>
           <a:prstGeom prst="rect">
             <a:avLst/>
@@ -253,36 +253,36 @@
         <p:spPr>
           <a:xfrm>
             <a:off x="457200" y="1600200"/>
-            <a:ext cx="6858000" cy="4572000"/>
-          </a:xfrm>
-          <a:prstGeom prst="rect">
-            <a:avLst/>
-          </a:prstGeom>
-          <a:noFill/>
-          <a:ln>
-            <a:noFill/>
-          </a:ln>
-        </p:spPr>
-        <p:txBody>
-          <a:bodyPr wrap="square"/>
-          <a:lstStyle/>
-          <a:p>
-            <a:r>
-              <a:rPr lang="ko-KR" sz="1800"/>
+            <a:ext cx="3429000" cy="4572000"/>
+          </a:xfrm>
+          <a:prstGeom prst="rect">
+            <a:avLst/>
+          </a:prstGeom>
+          <a:noFill/>
+          <a:ln>
+            <a:noFill/>
+          </a:ln>
+        </p:spPr>
+        <p:txBody>
+          <a:bodyPr wrap="square"/>
+          <a:lstStyle/>
+          <a:p>
+            <a:r>
+              <a:rPr lang="ko-KR" sz="1700"/>
               <a:t>• when to use each correction path</a:t>
             </a:r>
             <a:endParaRPr lang="ko-KR"/>
           </a:p>
           <a:p>
             <a:r>
-              <a:rPr lang="ko-KR" sz="1800"/>
+              <a:rPr lang="ko-KR" sz="1700"/>
               <a:t>• what to confirm after execution</a:t>
             </a:r>
             <a:endParaRPr lang="ko-KR"/>
           </a:p>
           <a:p>
             <a:r>
-              <a:rPr lang="ko-KR" sz="1800"/>
+              <a:rPr lang="ko-KR" sz="1700"/>
               <a:t>• audit detail, actor lineage, memo, result code, and downstream impact</a:t>
             </a:r>
             <a:endParaRPr lang="ko-KR"/>
@@ -297,8 +297,8 @@
         </p:nvSpPr>
         <p:spPr>
           <a:xfrm>
-            <a:off x="7543800" y="1600200"/>
-            <a:ext cx="3200400" cy="4572000"/>
+            <a:off x="4343400" y="1600200"/>
+            <a:ext cx="7391400" cy="4572000"/>
           </a:xfrm>
           <a:prstGeom prst="rect">
             <a:avLst/>
@@ -399,36 +399,36 @@
         <p:spPr>
           <a:xfrm>
             <a:off x="457200" y="1600200"/>
-            <a:ext cx="6858000" cy="4572000"/>
-          </a:xfrm>
-          <a:prstGeom prst="rect">
-            <a:avLst/>
-          </a:prstGeom>
-          <a:noFill/>
-          <a:ln>
-            <a:noFill/>
-          </a:ln>
-        </p:spPr>
-        <p:txBody>
-          <a:bodyPr wrap="square"/>
-          <a:lstStyle/>
-          <a:p>
-            <a:r>
-              <a:rPr lang="ko-KR" sz="1800"/>
+            <a:ext cx="3429000" cy="4572000"/>
+          </a:xfrm>
+          <a:prstGeom prst="rect">
+            <a:avLst/>
+          </a:prstGeom>
+          <a:noFill/>
+          <a:ln>
+            <a:noFill/>
+          </a:ln>
+        </p:spPr>
+        <p:txBody>
+          <a:bodyPr wrap="square"/>
+          <a:lstStyle/>
+          <a:p>
+            <a:r>
+              <a:rPr lang="ko-KR" sz="1700"/>
               <a:t>• replay request create, monitor, and cancel</a:t>
             </a:r>
             <a:endParaRPr lang="ko-KR"/>
           </a:p>
           <a:p>
             <a:r>
-              <a:rPr lang="ko-KR" sz="1800"/>
+              <a:rPr lang="ko-KR" sz="1700"/>
               <a:t>• billing export create, inspect, rerun, recreate, or cancel</a:t>
             </a:r>
             <a:endParaRPr lang="ko-KR"/>
           </a:p>
           <a:p>
             <a:r>
-              <a:rPr lang="ko-KR" sz="1800"/>
+              <a:rPr lang="ko-KR" sz="1700"/>
               <a:t>• processing state versus failed state versus quiet state</a:t>
             </a:r>
             <a:endParaRPr lang="ko-KR"/>
@@ -443,8 +443,8 @@
         </p:nvSpPr>
         <p:spPr>
           <a:xfrm>
-            <a:off x="7543800" y="1600200"/>
-            <a:ext cx="3200400" cy="4572000"/>
+            <a:off x="4343400" y="1600200"/>
+            <a:ext cx="7391400" cy="4572000"/>
           </a:xfrm>
           <a:prstGeom prst="rect">
             <a:avLst/>
@@ -545,43 +545,43 @@
         <p:spPr>
           <a:xfrm>
             <a:off x="457200" y="1600200"/>
-            <a:ext cx="6858000" cy="4572000"/>
-          </a:xfrm>
-          <a:prstGeom prst="rect">
-            <a:avLst/>
-          </a:prstGeom>
-          <a:noFill/>
-          <a:ln>
-            <a:noFill/>
-          </a:ln>
-        </p:spPr>
-        <p:txBody>
-          <a:bodyPr wrap="square"/>
-          <a:lstStyle/>
-          <a:p>
-            <a:r>
-              <a:rPr lang="ko-KR" sz="1800"/>
+            <a:ext cx="3429000" cy="4572000"/>
+          </a:xfrm>
+          <a:prstGeom prst="rect">
+            <a:avLst/>
+          </a:prstGeom>
+          <a:noFill/>
+          <a:ln>
+            <a:noFill/>
+          </a:ln>
+        </p:spPr>
+        <p:txBody>
+          <a:bodyPr wrap="square"/>
+          <a:lstStyle/>
+          <a:p>
+            <a:r>
+              <a:rPr lang="ko-KR" sz="1700"/>
               <a:t>• operational-event timeline</a:t>
             </a:r>
             <a:endParaRPr lang="ko-KR"/>
           </a:p>
           <a:p>
             <a:r>
-              <a:rPr lang="ko-KR" sz="1800"/>
+              <a:rPr lang="ko-KR" sz="1700"/>
               <a:t>• action snapshot</a:t>
             </a:r>
             <a:endParaRPr lang="ko-KR"/>
           </a:p>
           <a:p>
             <a:r>
-              <a:rPr lang="ko-KR" sz="1800"/>
+              <a:rPr lang="ko-KR" sz="1700"/>
               <a:t>• created actor and updated actor on admin-managed rows</a:t>
             </a:r>
             <a:endParaRPr lang="ko-KR"/>
           </a:p>
           <a:p>
             <a:r>
-              <a:rPr lang="ko-KR" sz="1800"/>
+              <a:rPr lang="ko-KR" sz="1700"/>
               <a:t>• user action audit evidence meaning</a:t>
             </a:r>
             <a:endParaRPr lang="ko-KR"/>
@@ -596,8 +596,8 @@
         </p:nvSpPr>
         <p:spPr>
           <a:xfrm>
-            <a:off x="7543800" y="1600200"/>
-            <a:ext cx="3200400" cy="4572000"/>
+            <a:off x="4343400" y="1600200"/>
+            <a:ext cx="7391400" cy="4572000"/>
           </a:xfrm>
           <a:prstGeom prst="rect">
             <a:avLst/>
@@ -698,50 +698,50 @@
         <p:spPr>
           <a:xfrm>
             <a:off x="457200" y="1600200"/>
-            <a:ext cx="6858000" cy="4572000"/>
-          </a:xfrm>
-          <a:prstGeom prst="rect">
-            <a:avLst/>
-          </a:prstGeom>
-          <a:noFill/>
-          <a:ln>
-            <a:noFill/>
-          </a:ln>
-        </p:spPr>
-        <p:txBody>
-          <a:bodyPr wrap="square"/>
-          <a:lstStyle/>
-          <a:p>
-            <a:r>
-              <a:rPr lang="ko-KR" sz="1800"/>
+            <a:ext cx="3429000" cy="4572000"/>
+          </a:xfrm>
+          <a:prstGeom prst="rect">
+            <a:avLst/>
+          </a:prstGeom>
+          <a:noFill/>
+          <a:ln>
+            <a:noFill/>
+          </a:ln>
+        </p:spPr>
+        <p:txBody>
+          <a:bodyPr wrap="square"/>
+          <a:lstStyle/>
+          <a:p>
+            <a:r>
+              <a:rPr lang="ko-KR" sz="1700"/>
               <a:t>• stale adapter</a:t>
             </a:r>
             <a:endParaRPr lang="ko-KR"/>
           </a:p>
           <a:p>
             <a:r>
-              <a:rPr lang="ko-KR" sz="1800"/>
+              <a:rPr lang="ko-KR" sz="1700"/>
               <a:t>• failed replay</a:t>
             </a:r>
             <a:endParaRPr lang="ko-KR"/>
           </a:p>
           <a:p>
             <a:r>
-              <a:rPr lang="ko-KR" sz="1800"/>
+              <a:rPr lang="ko-KR" sz="1700"/>
               <a:t>• failed export</a:t>
             </a:r>
             <a:endParaRPr lang="ko-KR"/>
           </a:p>
           <a:p>
             <a:r>
-              <a:rPr lang="ko-KR" sz="1800"/>
+              <a:rPr lang="ko-KR" sz="1700"/>
               <a:t>• blocking VEE</a:t>
             </a:r>
             <a:endParaRPr lang="ko-KR"/>
           </a:p>
           <a:p>
             <a:r>
-              <a:rPr lang="ko-KR" sz="1800"/>
+              <a:rPr lang="ko-KR" sz="1700"/>
               <a:t>• missing master data</a:t>
             </a:r>
             <a:endParaRPr lang="ko-KR"/>
@@ -756,8 +756,8 @@
         </p:nvSpPr>
         <p:spPr>
           <a:xfrm>
-            <a:off x="7543800" y="1600200"/>
-            <a:ext cx="3200400" cy="4572000"/>
+            <a:off x="4343400" y="1600200"/>
+            <a:ext cx="7391400" cy="4572000"/>
           </a:xfrm>
           <a:prstGeom prst="rect">
             <a:avLst/>
@@ -858,92 +858,92 @@
         <p:spPr>
           <a:xfrm>
             <a:off x="457200" y="1600200"/>
-            <a:ext cx="6858000" cy="4572000"/>
-          </a:xfrm>
-          <a:prstGeom prst="rect">
-            <a:avLst/>
-          </a:prstGeom>
-          <a:noFill/>
-          <a:ln>
-            <a:noFill/>
-          </a:ln>
-        </p:spPr>
-        <p:txBody>
-          <a:bodyPr wrap="square"/>
-          <a:lstStyle/>
-          <a:p>
-            <a:r>
-              <a:rPr lang="ko-KR" sz="1800"/>
+            <a:ext cx="3429000" cy="4572000"/>
+          </a:xfrm>
+          <a:prstGeom prst="rect">
+            <a:avLst/>
+          </a:prstGeom>
+          <a:noFill/>
+          <a:ln>
+            <a:noFill/>
+          </a:ln>
+        </p:spPr>
+        <p:txBody>
+          <a:bodyPr wrap="square"/>
+          <a:lstStyle/>
+          <a:p>
+            <a:r>
+              <a:rPr lang="ko-KR" sz="1700"/>
               <a:t>• end-of-day checks</a:t>
             </a:r>
             <a:endParaRPr lang="ko-KR"/>
           </a:p>
           <a:p>
             <a:r>
-              <a:rPr lang="ko-KR" sz="1800"/>
+              <a:rPr lang="ko-KR" sz="1700"/>
               <a:t>• whether to keep the local environment running</a:t>
             </a:r>
             <a:endParaRPr lang="ko-KR"/>
           </a:p>
           <a:p>
             <a:r>
-              <a:rPr lang="ko-KR" sz="1800"/>
+              <a:rPr lang="ko-KR" sz="1700"/>
               <a:t>• current preproduct limitations</a:t>
             </a:r>
             <a:endParaRPr lang="ko-KR"/>
           </a:p>
           <a:p>
             <a:r>
-              <a:rPr lang="ko-KR" sz="1800"/>
+              <a:rPr lang="ko-KR" sz="1700"/>
               <a:t>• escalation posture for repeated failures</a:t>
             </a:r>
             <a:endParaRPr lang="ko-KR"/>
           </a:p>
           <a:p>
             <a:r>
-              <a:rPr lang="ko-KR" sz="1800"/>
+              <a:rPr lang="ko-KR" sz="1700"/>
               <a:t>## Packaging notes</a:t>
             </a:r>
             <a:endParaRPr lang="ko-KR"/>
           </a:p>
           <a:p>
             <a:r>
-              <a:rPr lang="ko-KR" sz="1800"/>
+              <a:rPr lang="ko-KR" sz="1700"/>
               <a:t>For the first training deck:</a:t>
             </a:r>
             <a:endParaRPr lang="ko-KR"/>
           </a:p>
           <a:p>
             <a:r>
-              <a:rPr lang="ko-KR" sz="1800"/>
+              <a:rPr lang="ko-KR" sz="1700"/>
               <a:t>• prefer Korean UI captures</a:t>
             </a:r>
             <a:endParaRPr lang="ko-KR"/>
           </a:p>
           <a:p>
             <a:r>
-              <a:rPr lang="ko-KR" sz="1800"/>
+              <a:rPr lang="ko-KR" sz="1700"/>
               <a:t>• use the same account names consistently across screenshots</a:t>
             </a:r>
             <a:endParaRPr lang="ko-KR"/>
           </a:p>
           <a:p>
             <a:r>
-              <a:rPr lang="ko-KR" sz="1800"/>
+              <a:rPr lang="ko-KR" sz="1700"/>
               <a:t>• mask secrets, credentials, and environment-specific identifiers</a:t>
             </a:r>
             <a:endParaRPr lang="ko-KR"/>
           </a:p>
           <a:p>
             <a:r>
-              <a:rPr lang="ko-KR" sz="1800"/>
+              <a:rPr lang="ko-KR" sz="1700"/>
               <a:t>• keep one wide desktop viewport across the whole deck</a:t>
             </a:r>
             <a:endParaRPr lang="ko-KR"/>
           </a:p>
           <a:p>
             <a:r>
-              <a:rPr lang="ko-KR" sz="1800"/>
+              <a:rPr lang="ko-KR" sz="1700"/>
               <a:t>• reserve space for captions that explain what the operator should look at first</a:t>
             </a:r>
             <a:endParaRPr lang="ko-KR"/>
@@ -958,8 +958,8 @@
         </p:nvSpPr>
         <p:spPr>
           <a:xfrm>
-            <a:off x="7543800" y="1600200"/>
-            <a:ext cx="3200400" cy="4572000"/>
+            <a:off x="4343400" y="1600200"/>
+            <a:ext cx="7391400" cy="4572000"/>
           </a:xfrm>
           <a:prstGeom prst="rect">
             <a:avLst/>
@@ -1060,50 +1060,50 @@
         <p:spPr>
           <a:xfrm>
             <a:off x="457200" y="1600200"/>
-            <a:ext cx="6858000" cy="4572000"/>
-          </a:xfrm>
-          <a:prstGeom prst="rect">
-            <a:avLst/>
-          </a:prstGeom>
-          <a:noFill/>
-          <a:ln>
-            <a:noFill/>
-          </a:ln>
-        </p:spPr>
-        <p:txBody>
-          <a:bodyPr wrap="square"/>
-          <a:lstStyle/>
-          <a:p>
-            <a:r>
-              <a:rPr lang="ko-KR" sz="1800"/>
+            <a:ext cx="3429000" cy="4572000"/>
+          </a:xfrm>
+          <a:prstGeom prst="rect">
+            <a:avLst/>
+          </a:prstGeom>
+          <a:noFill/>
+          <a:ln>
+            <a:noFill/>
+          </a:ln>
+        </p:spPr>
+        <p:txBody>
+          <a:bodyPr wrap="square"/>
+          <a:lstStyle/>
+          <a:p>
+            <a:r>
+              <a:rPr lang="ko-KR" sz="1700"/>
               <a:t>• PostgreSQL</a:t>
             </a:r>
             <a:endParaRPr lang="ko-KR"/>
           </a:p>
           <a:p>
             <a:r>
-              <a:rPr lang="ko-KR" sz="1800"/>
+              <a:rPr lang="ko-KR" sz="1700"/>
               <a:t>• Flask web UI</a:t>
             </a:r>
             <a:endParaRPr lang="ko-KR"/>
           </a:p>
           <a:p>
             <a:r>
-              <a:rPr lang="ko-KR" sz="1800"/>
+              <a:rPr lang="ko-KR" sz="1700"/>
               <a:t>• adapter queue commands</a:t>
             </a:r>
             <a:endParaRPr lang="ko-KR"/>
           </a:p>
           <a:p>
             <a:r>
-              <a:rPr lang="ko-KR" sz="1800"/>
+              <a:rPr lang="ko-KR" sz="1700"/>
               <a:t>• HES, adapter, VEE, replay, export, and operational-event as the main operator</a:t>
             </a:r>
             <a:endParaRPr lang="ko-KR"/>
           </a:p>
           <a:p>
             <a:r>
-              <a:rPr lang="ko-KR" sz="1800"/>
+              <a:rPr lang="ko-KR" sz="1700"/>
               <a:t>objects</a:t>
             </a:r>
             <a:endParaRPr lang="ko-KR"/>
@@ -1118,8 +1118,8 @@
         </p:nvSpPr>
         <p:spPr>
           <a:xfrm>
-            <a:off x="7543800" y="1600200"/>
-            <a:ext cx="3200400" cy="4572000"/>
+            <a:off x="4343400" y="1600200"/>
+            <a:ext cx="7391400" cy="4572000"/>
           </a:xfrm>
           <a:prstGeom prst="rect">
             <a:avLst/>
@@ -1220,57 +1220,57 @@
         <p:spPr>
           <a:xfrm>
             <a:off x="457200" y="1600200"/>
-            <a:ext cx="6858000" cy="4572000"/>
-          </a:xfrm>
-          <a:prstGeom prst="rect">
-            <a:avLst/>
-          </a:prstGeom>
-          <a:noFill/>
-          <a:ln>
-            <a:noFill/>
-          </a:ln>
-        </p:spPr>
-        <p:txBody>
-          <a:bodyPr wrap="square"/>
-          <a:lstStyle/>
-          <a:p>
-            <a:r>
-              <a:rPr lang="ko-KR" sz="1800"/>
+            <a:ext cx="3429000" cy="4572000"/>
+          </a:xfrm>
+          <a:prstGeom prst="rect">
+            <a:avLst/>
+          </a:prstGeom>
+          <a:noFill/>
+          <a:ln>
+            <a:noFill/>
+          </a:ln>
+        </p:spPr>
+        <p:txBody>
+          <a:bodyPr wrap="square"/>
+          <a:lstStyle/>
+          <a:p>
+            <a:r>
+              <a:rPr lang="ko-KR" sz="1700"/>
               <a:t>• verify PostgreSQL</a:t>
             </a:r>
             <a:endParaRPr lang="ko-KR"/>
           </a:p>
           <a:p>
             <a:r>
-              <a:rPr lang="ko-KR" sz="1800"/>
+              <a:rPr lang="ko-KR" sz="1700"/>
               <a:t>• activate environment</a:t>
             </a:r>
             <a:endParaRPr lang="ko-KR"/>
           </a:p>
           <a:p>
             <a:r>
-              <a:rPr lang="ko-KR" sz="1800"/>
+              <a:rPr lang="ko-KR" sz="1700"/>
               <a:t>• first-time bootstrap commands only when needed</a:t>
             </a:r>
             <a:endParaRPr lang="ko-KR"/>
           </a:p>
           <a:p>
             <a:r>
-              <a:rPr lang="ko-KR" sz="1800"/>
+              <a:rPr lang="ko-KR" sz="1700"/>
               <a:t>• start make run</a:t>
             </a:r>
             <a:endParaRPr lang="ko-KR"/>
           </a:p>
           <a:p>
             <a:r>
-              <a:rPr lang="ko-KR" sz="1800"/>
+              <a:rPr lang="ko-KR" sz="1700"/>
               <a:t>• run adapter queue commands in separate shells when needed</a:t>
             </a:r>
             <a:endParaRPr lang="ko-KR"/>
           </a:p>
           <a:p>
             <a:r>
-              <a:rPr lang="ko-KR" sz="1800"/>
+              <a:rPr lang="ko-KR" sz="1700"/>
               <a:t>• post-start checks</a:t>
             </a:r>
             <a:endParaRPr lang="ko-KR"/>
@@ -1285,8 +1285,8 @@
         </p:nvSpPr>
         <p:spPr>
           <a:xfrm>
-            <a:off x="7543800" y="1600200"/>
-            <a:ext cx="3200400" cy="4572000"/>
+            <a:off x="4343400" y="1600200"/>
+            <a:ext cx="7391400" cy="4572000"/>
           </a:xfrm>
           <a:prstGeom prst="rect">
             <a:avLst/>
@@ -1387,50 +1387,50 @@
         <p:spPr>
           <a:xfrm>
             <a:off x="457200" y="1600200"/>
-            <a:ext cx="6858000" cy="4572000"/>
-          </a:xfrm>
-          <a:prstGeom prst="rect">
-            <a:avLst/>
-          </a:prstGeom>
-          <a:noFill/>
-          <a:ln>
-            <a:noFill/>
-          </a:ln>
-        </p:spPr>
-        <p:txBody>
-          <a:bodyPr wrap="square"/>
-          <a:lstStyle/>
-          <a:p>
-            <a:r>
-              <a:rPr lang="ko-KR" sz="1800"/>
+            <a:ext cx="3429000" cy="4572000"/>
+          </a:xfrm>
+          <a:prstGeom prst="rect">
+            <a:avLst/>
+          </a:prstGeom>
+          <a:noFill/>
+          <a:ln>
+            <a:noFill/>
+          </a:ln>
+        </p:spPr>
+        <p:txBody>
+          <a:bodyPr wrap="square"/>
+          <a:lstStyle/>
+          <a:p>
+            <a:r>
+              <a:rPr lang="ko-KR" sz="1700"/>
               <a:t>• check in-flight replay, export, and adapter work</a:t>
             </a:r>
             <a:endParaRPr lang="ko-KR"/>
           </a:p>
           <a:p>
             <a:r>
-              <a:rPr lang="ko-KR" sz="1800"/>
+              <a:rPr lang="ko-KR" sz="1700"/>
               <a:t>• stop worker shells first</a:t>
             </a:r>
             <a:endParaRPr lang="ko-KR"/>
           </a:p>
           <a:p>
             <a:r>
-              <a:rPr lang="ko-KR" sz="1800"/>
+              <a:rPr lang="ko-KR" sz="1700"/>
               <a:t>• stop Flask</a:t>
             </a:r>
             <a:endParaRPr lang="ko-KR"/>
           </a:p>
           <a:p>
             <a:r>
-              <a:rPr lang="ko-KR" sz="1800"/>
+              <a:rPr lang="ko-KR" sz="1700"/>
               <a:t>• stop PostgreSQL only when appropriate</a:t>
             </a:r>
             <a:endParaRPr lang="ko-KR"/>
           </a:p>
           <a:p>
             <a:r>
-              <a:rPr lang="ko-KR" sz="1800"/>
+              <a:rPr lang="ko-KR" sz="1700"/>
               <a:t>• restart after abnormal stop</a:t>
             </a:r>
             <a:endParaRPr lang="ko-KR"/>
@@ -1445,8 +1445,8 @@
         </p:nvSpPr>
         <p:spPr>
           <a:xfrm>
-            <a:off x="7543800" y="1600200"/>
-            <a:ext cx="3200400" cy="4572000"/>
+            <a:off x="4343400" y="1600200"/>
+            <a:ext cx="7391400" cy="4572000"/>
           </a:xfrm>
           <a:prstGeom prst="rect">
             <a:avLst/>
@@ -1547,50 +1547,50 @@
         <p:spPr>
           <a:xfrm>
             <a:off x="457200" y="1600200"/>
-            <a:ext cx="6858000" cy="4572000"/>
-          </a:xfrm>
-          <a:prstGeom prst="rect">
-            <a:avLst/>
-          </a:prstGeom>
-          <a:noFill/>
-          <a:ln>
-            <a:noFill/>
-          </a:ln>
-        </p:spPr>
-        <p:txBody>
-          <a:bodyPr wrap="square"/>
-          <a:lstStyle/>
-          <a:p>
-            <a:r>
-              <a:rPr lang="ko-KR" sz="1800"/>
+            <a:ext cx="3429000" cy="4572000"/>
+          </a:xfrm>
+          <a:prstGeom prst="rect">
+            <a:avLst/>
+          </a:prstGeom>
+          <a:noFill/>
+          <a:ln>
+            <a:noFill/>
+          </a:ln>
+        </p:spPr>
+        <p:txBody>
+          <a:bodyPr wrap="square"/>
+          <a:lstStyle/>
+          <a:p>
+            <a:r>
+              <a:rPr lang="ko-KR" sz="1700"/>
               <a:t>• log in</a:t>
             </a:r>
             <a:endParaRPr lang="ko-KR"/>
           </a:p>
           <a:p>
             <a:r>
-              <a:rPr lang="ko-KR" sz="1800"/>
+              <a:rPr lang="ko-KR" sz="1700"/>
               <a:t>• open dashboard</a:t>
             </a:r>
             <a:endParaRPr lang="ko-KR"/>
           </a:p>
           <a:p>
             <a:r>
-              <a:rPr lang="ko-KR" sz="1800"/>
+              <a:rPr lang="ko-KR" sz="1700"/>
               <a:t>• review open alerts</a:t>
             </a:r>
             <a:endParaRPr lang="ko-KR"/>
           </a:p>
           <a:p>
             <a:r>
-              <a:rPr lang="ko-KR" sz="1800"/>
+              <a:rPr lang="ko-KR" sz="1700"/>
               <a:t>• review recent operational events</a:t>
             </a:r>
             <a:endParaRPr lang="ko-KR"/>
           </a:p>
           <a:p>
             <a:r>
-              <a:rPr lang="ko-KR" sz="1800"/>
+              <a:rPr lang="ko-KR" sz="1700"/>
               <a:t>• identify stale adapters, failed replay, failed export, or blocking VEE</a:t>
             </a:r>
             <a:endParaRPr lang="ko-KR"/>
@@ -1605,8 +1605,8 @@
         </p:nvSpPr>
         <p:spPr>
           <a:xfrm>
-            <a:off x="7543800" y="1600200"/>
-            <a:ext cx="3200400" cy="4572000"/>
+            <a:off x="4343400" y="1600200"/>
+            <a:ext cx="7391400" cy="4572000"/>
           </a:xfrm>
           <a:prstGeom prst="rect">
             <a:avLst/>
@@ -1707,43 +1707,43 @@
         <p:spPr>
           <a:xfrm>
             <a:off x="457200" y="1600200"/>
-            <a:ext cx="6858000" cy="4572000"/>
-          </a:xfrm>
-          <a:prstGeom prst="rect">
-            <a:avLst/>
-          </a:prstGeom>
-          <a:noFill/>
-          <a:ln>
-            <a:noFill/>
-          </a:ln>
-        </p:spPr>
-        <p:txBody>
-          <a:bodyPr wrap="square"/>
-          <a:lstStyle/>
-          <a:p>
-            <a:r>
-              <a:rPr lang="ko-KR" sz="1800"/>
+            <a:ext cx="3429000" cy="4572000"/>
+          </a:xfrm>
+          <a:prstGeom prst="rect">
+            <a:avLst/>
+          </a:prstGeom>
+          <a:noFill/>
+          <a:ln>
+            <a:noFill/>
+          </a:ln>
+        </p:spPr>
+        <p:txBody>
+          <a:bodyPr wrap="square"/>
+          <a:lstStyle/>
+          <a:p>
+            <a:r>
+              <a:rPr lang="ko-KR" sz="1700"/>
               <a:t>• HES list and detail</a:t>
             </a:r>
             <a:endParaRPr lang="ko-KR"/>
           </a:p>
           <a:p>
             <a:r>
-              <a:rPr lang="ko-KR" sz="1800"/>
+              <a:rPr lang="ko-KR" sz="1700"/>
               <a:t>• adapter list and detail</a:t>
             </a:r>
             <a:endParaRPr lang="ko-KR"/>
           </a:p>
           <a:p>
             <a:r>
-              <a:rPr lang="ko-KR" sz="1800"/>
+              <a:rPr lang="ko-KR" sz="1700"/>
               <a:t>• Enable, Pause, Run Once</a:t>
             </a:r>
             <a:endParaRPr lang="ko-KR"/>
           </a:p>
           <a:p>
             <a:r>
-              <a:rPr lang="ko-KR" sz="1800"/>
+              <a:rPr lang="ko-KR" sz="1700"/>
               <a:t>• runtime versus human actor interpretation</a:t>
             </a:r>
             <a:endParaRPr lang="ko-KR"/>
@@ -1758,8 +1758,8 @@
         </p:nvSpPr>
         <p:spPr>
           <a:xfrm>
-            <a:off x="7543800" y="1600200"/>
-            <a:ext cx="3200400" cy="4572000"/>
+            <a:off x="4343400" y="1600200"/>
+            <a:ext cx="7391400" cy="4572000"/>
           </a:xfrm>
           <a:prstGeom prst="rect">
             <a:avLst/>
@@ -1860,50 +1860,50 @@
         <p:spPr>
           <a:xfrm>
             <a:off x="457200" y="1600200"/>
-            <a:ext cx="6858000" cy="4572000"/>
-          </a:xfrm>
-          <a:prstGeom prst="rect">
-            <a:avLst/>
-          </a:prstGeom>
-          <a:noFill/>
-          <a:ln>
-            <a:noFill/>
-          </a:ln>
-        </p:spPr>
-        <p:txBody>
-          <a:bodyPr wrap="square"/>
-          <a:lstStyle/>
-          <a:p>
-            <a:r>
-              <a:rPr lang="ko-KR" sz="1800"/>
+            <a:ext cx="3429000" cy="4572000"/>
+          </a:xfrm>
+          <a:prstGeom prst="rect">
+            <a:avLst/>
+          </a:prstGeom>
+          <a:noFill/>
+          <a:ln>
+            <a:noFill/>
+          </a:ln>
+        </p:spPr>
+        <p:txBody>
+          <a:bodyPr wrap="square"/>
+          <a:lstStyle/>
+          <a:p>
+            <a:r>
+              <a:rPr lang="ko-KR" sz="1700"/>
               <a:t>• service point</a:t>
             </a:r>
             <a:endParaRPr lang="ko-KR"/>
           </a:p>
           <a:p>
             <a:r>
-              <a:rPr lang="ko-KR" sz="1800"/>
+              <a:rPr lang="ko-KR" sz="1700"/>
               <a:t>• device</a:t>
             </a:r>
             <a:endParaRPr lang="ko-KR"/>
           </a:p>
           <a:p>
             <a:r>
-              <a:rPr lang="ko-KR" sz="1800"/>
+              <a:rPr lang="ko-KR" sz="1700"/>
               <a:t>• measuring component</a:t>
             </a:r>
             <a:endParaRPr lang="ko-KR"/>
           </a:p>
           <a:p>
             <a:r>
-              <a:rPr lang="ko-KR" sz="1800"/>
+              <a:rPr lang="ko-KR" sz="1700"/>
               <a:t>• installation history</a:t>
             </a:r>
             <a:endParaRPr lang="ko-KR"/>
           </a:p>
           <a:p>
             <a:r>
-              <a:rPr lang="ko-KR" sz="1800"/>
+              <a:rPr lang="ko-KR" sz="1700"/>
               <a:t>• why mapping fails when these are missing</a:t>
             </a:r>
             <a:endParaRPr lang="ko-KR"/>
@@ -1918,8 +1918,8 @@
         </p:nvSpPr>
         <p:spPr>
           <a:xfrm>
-            <a:off x="7543800" y="1600200"/>
-            <a:ext cx="3200400" cy="4572000"/>
+            <a:off x="4343400" y="1600200"/>
+            <a:ext cx="7391400" cy="4572000"/>
           </a:xfrm>
           <a:prstGeom prst="rect">
             <a:avLst/>
@@ -2020,43 +2020,43 @@
         <p:spPr>
           <a:xfrm>
             <a:off x="457200" y="1600200"/>
-            <a:ext cx="6858000" cy="4572000"/>
-          </a:xfrm>
-          <a:prstGeom prst="rect">
-            <a:avLst/>
-          </a:prstGeom>
-          <a:noFill/>
-          <a:ln>
-            <a:noFill/>
-          </a:ln>
-        </p:spPr>
-        <p:txBody>
-          <a:bodyPr wrap="square"/>
-          <a:lstStyle/>
-          <a:p>
-            <a:r>
-              <a:rPr lang="ko-KR" sz="1800"/>
+            <a:ext cx="3429000" cy="4572000"/>
+          </a:xfrm>
+          <a:prstGeom prst="rect">
+            <a:avLst/>
+          </a:prstGeom>
+          <a:noFill/>
+          <a:ln>
+            <a:noFill/>
+          </a:ln>
+        </p:spPr>
+        <p:txBody>
+          <a:bodyPr wrap="square"/>
+          <a:lstStyle/>
+          <a:p>
+            <a:r>
+              <a:rPr lang="ko-KR" sz="1700"/>
               <a:t>• review raw reads and raw events first</a:t>
             </a:r>
             <a:endParaRPr lang="ko-KR"/>
           </a:p>
           <a:p>
             <a:r>
-              <a:rPr lang="ko-KR" sz="1800"/>
+              <a:rPr lang="ko-KR" sz="1700"/>
               <a:t>• confirm canonical progression</a:t>
             </a:r>
             <a:endParaRPr lang="ko-KR"/>
           </a:p>
           <a:p>
             <a:r>
-              <a:rPr lang="ko-KR" sz="1800"/>
+              <a:rPr lang="ko-KR" sz="1700"/>
               <a:t>• confirm final authoritative state</a:t>
             </a:r>
             <a:endParaRPr lang="ko-KR"/>
           </a:p>
           <a:p>
             <a:r>
-              <a:rPr lang="ko-KR" sz="1800"/>
+              <a:rPr lang="ko-KR" sz="1700"/>
               <a:t>• use lineage screens to trace one sample end to end</a:t>
             </a:r>
             <a:endParaRPr lang="ko-KR"/>
@@ -2071,8 +2071,8 @@
         </p:nvSpPr>
         <p:spPr>
           <a:xfrm>
-            <a:off x="7543800" y="1600200"/>
-            <a:ext cx="3200400" cy="4572000"/>
+            <a:off x="4343400" y="1600200"/>
+            <a:ext cx="7391400" cy="4572000"/>
           </a:xfrm>
           <a:prstGeom prst="rect">
             <a:avLst/>
@@ -2173,43 +2173,43 @@
         <p:spPr>
           <a:xfrm>
             <a:off x="457200" y="1600200"/>
-            <a:ext cx="6858000" cy="4572000"/>
-          </a:xfrm>
-          <a:prstGeom prst="rect">
-            <a:avLst/>
-          </a:prstGeom>
-          <a:noFill/>
-          <a:ln>
-            <a:noFill/>
-          </a:ln>
-        </p:spPr>
-        <p:txBody>
-          <a:bodyPr wrap="square"/>
-          <a:lstStyle/>
-          <a:p>
-            <a:r>
-              <a:rPr lang="ko-KR" sz="1800"/>
+            <a:ext cx="3429000" cy="4572000"/>
+          </a:xfrm>
+          <a:prstGeom prst="rect">
+            <a:avLst/>
+          </a:prstGeom>
+          <a:noFill/>
+          <a:ln>
+            <a:noFill/>
+          </a:ln>
+        </p:spPr>
+        <p:txBody>
+          <a:bodyPr wrap="square"/>
+          <a:lstStyle/>
+          <a:p>
+            <a:r>
+              <a:rPr lang="ko-KR" sz="1700"/>
               <a:t>• start from the queue</a:t>
             </a:r>
             <a:endParaRPr lang="ko-KR"/>
           </a:p>
           <a:p>
             <a:r>
-              <a:rPr lang="ko-KR" sz="1800"/>
+              <a:rPr lang="ko-KR" sz="1700"/>
               <a:t>• prioritize blocking items</a:t>
             </a:r>
             <a:endParaRPr lang="ko-KR"/>
           </a:p>
           <a:p>
             <a:r>
-              <a:rPr lang="ko-KR" sz="1800"/>
+              <a:rPr lang="ko-KR" sz="1700"/>
               <a:t>• use detail view for blocked reason, event context, and next action</a:t>
             </a:r>
             <a:endParaRPr lang="ko-KR"/>
           </a:p>
           <a:p>
             <a:r>
-              <a:rPr lang="ko-KR" sz="1800"/>
+              <a:rPr lang="ko-KR" sz="1700"/>
               <a:t>• understand re-evaluate versus correction</a:t>
             </a:r>
             <a:endParaRPr lang="ko-KR"/>
@@ -2224,8 +2224,8 @@
         </p:nvSpPr>
         <p:spPr>
           <a:xfrm>
-            <a:off x="7543800" y="1600200"/>
-            <a:ext cx="3200400" cy="4572000"/>
+            <a:off x="4343400" y="1600200"/>
+            <a:ext cx="7391400" cy="4572000"/>
           </a:xfrm>
           <a:prstGeom prst="rect">
             <a:avLst/>

</xml_diff>

<commit_message>
Add preproduct menu map package
</commit_message>
<xml_diff>
--- a/docs/generated/mdms-preproduct-operator-training-draft.pptx
+++ b/docs/generated/mdms-preproduct-operator-training-draft.pptx
@@ -63,7 +63,11 @@
           <a:lstStyle/>
           <a:p>
             <a:r>
-              <a:rPr lang="ko-KR" sz="2600" b="1"/>
+              <a:rPr lang="ko-KR" sz="2600" b="1">
+                <a:solidFill>
+                  <a:srgbClr val="0F172A"/>
+                </a:solidFill>
+              </a:rPr>
               <a:t>Slide 1. Title and scope</a:t>
             </a:r>
             <a:endParaRPr lang="ko-KR"/>
@@ -94,49 +98,77 @@
           <a:lstStyle/>
           <a:p>
             <a:r>
-              <a:rPr lang="ko-KR" sz="1700"/>
+              <a:rPr lang="ko-KR" sz="1700">
+                <a:solidFill>
+                  <a:srgbClr val="0F172A"/>
+                </a:solidFill>
+              </a:rPr>
               <a:t>• title</a:t>
             </a:r>
             <a:endParaRPr lang="ko-KR"/>
           </a:p>
           <a:p>
             <a:r>
-              <a:rPr lang="ko-KR" sz="1700"/>
+              <a:rPr lang="ko-KR" sz="1700">
+                <a:solidFill>
+                  <a:srgbClr val="0F172A"/>
+                </a:solidFill>
+              </a:rPr>
               <a:t>  - MDMS Preproduct Operator Manual</a:t>
             </a:r>
             <a:endParaRPr lang="ko-KR"/>
           </a:p>
           <a:p>
             <a:r>
-              <a:rPr lang="ko-KR" sz="1700"/>
+              <a:rPr lang="ko-KR" sz="1700">
+                <a:solidFill>
+                  <a:srgbClr val="0F172A"/>
+                </a:solidFill>
+              </a:rPr>
               <a:t>• subtitle</a:t>
             </a:r>
             <a:endParaRPr lang="ko-KR"/>
           </a:p>
           <a:p>
             <a:r>
-              <a:rPr lang="ko-KR" sz="1700"/>
+              <a:rPr lang="ko-KR" sz="1700">
+                <a:solidFill>
+                  <a:srgbClr val="0F172A"/>
+                </a:solidFill>
+              </a:rPr>
               <a:t>  - bounded internal-use operating guide</a:t>
             </a:r>
             <a:endParaRPr lang="ko-KR"/>
           </a:p>
           <a:p>
             <a:r>
-              <a:rPr lang="ko-KR" sz="1700"/>
+              <a:rPr lang="ko-KR" sz="1700">
+                <a:solidFill>
+                  <a:srgbClr val="0F172A"/>
+                </a:solidFill>
+              </a:rPr>
               <a:t>• speaker focus</a:t>
             </a:r>
             <a:endParaRPr lang="ko-KR"/>
           </a:p>
           <a:p>
             <a:r>
-              <a:rPr lang="ko-KR" sz="1700"/>
+              <a:rPr lang="ko-KR" sz="1700">
+                <a:solidFill>
+                  <a:srgbClr val="0F172A"/>
+                </a:solidFill>
+              </a:rPr>
               <a:t>  - what this system currently supports</a:t>
             </a:r>
             <a:endParaRPr lang="ko-KR"/>
           </a:p>
           <a:p>
             <a:r>
-              <a:rPr lang="ko-KR" sz="1700"/>
+              <a:rPr lang="ko-KR" sz="1700">
+                <a:solidFill>
+                  <a:srgbClr val="0F172A"/>
+                </a:solidFill>
+              </a:rPr>
               <a:t>  - who should use admin versus operator</a:t>
             </a:r>
             <a:endParaRPr lang="ko-KR"/>
@@ -171,7 +203,11 @@
           <a:lstStyle/>
           <a:p>
             <a:r>
-              <a:rPr lang="ko-KR" sz="1600"/>
+              <a:rPr lang="ko-KR" sz="1600">
+                <a:solidFill>
+                  <a:srgbClr val="0F172A"/>
+                </a:solidFill>
+              </a:rPr>
               <a:t>Screen Capture Placeholder</a:t>
             </a:r>
             <a:endParaRPr lang="ko-KR"/>
@@ -181,7 +217,11 @@
           </a:p>
           <a:p>
             <a:r>
-              <a:rPr lang="ko-KR" sz="1600"/>
+              <a:rPr lang="ko-KR" sz="1600">
+                <a:solidFill>
+                  <a:srgbClr val="0F172A"/>
+                </a:solidFill>
+              </a:rPr>
               <a:t>• cover slide only or a simple dashboard background image later</a:t>
             </a:r>
             <a:endParaRPr lang="ko-KR"/>
@@ -237,7 +277,11 @@
           <a:lstStyle/>
           <a:p>
             <a:r>
-              <a:rPr lang="ko-KR" sz="2600" b="1"/>
+              <a:rPr lang="ko-KR" sz="2600" b="1">
+                <a:solidFill>
+                  <a:srgbClr val="0F172A"/>
+                </a:solidFill>
+              </a:rPr>
               <a:t>Slide 10. Estimation and manual edit</a:t>
             </a:r>
             <a:endParaRPr lang="ko-KR"/>
@@ -268,21 +312,33 @@
           <a:lstStyle/>
           <a:p>
             <a:r>
-              <a:rPr lang="ko-KR" sz="1700"/>
+              <a:rPr lang="ko-KR" sz="1700">
+                <a:solidFill>
+                  <a:srgbClr val="0F172A"/>
+                </a:solidFill>
+              </a:rPr>
               <a:t>• when to use each correction path</a:t>
             </a:r>
             <a:endParaRPr lang="ko-KR"/>
           </a:p>
           <a:p>
             <a:r>
-              <a:rPr lang="ko-KR" sz="1700"/>
+              <a:rPr lang="ko-KR" sz="1700">
+                <a:solidFill>
+                  <a:srgbClr val="0F172A"/>
+                </a:solidFill>
+              </a:rPr>
               <a:t>• what to confirm after execution</a:t>
             </a:r>
             <a:endParaRPr lang="ko-KR"/>
           </a:p>
           <a:p>
             <a:r>
-              <a:rPr lang="ko-KR" sz="1700"/>
+              <a:rPr lang="ko-KR" sz="1700">
+                <a:solidFill>
+                  <a:srgbClr val="0F172A"/>
+                </a:solidFill>
+              </a:rPr>
               <a:t>• audit detail, actor lineage, memo, result code, and downstream impact</a:t>
             </a:r>
             <a:endParaRPr lang="ko-KR"/>
@@ -317,7 +373,11 @@
           <a:lstStyle/>
           <a:p>
             <a:r>
-              <a:rPr lang="ko-KR" sz="1600"/>
+              <a:rPr lang="ko-KR" sz="1600">
+                <a:solidFill>
+                  <a:srgbClr val="0F172A"/>
+                </a:solidFill>
+              </a:rPr>
               <a:t>Screen Capture Placeholder</a:t>
             </a:r>
             <a:endParaRPr lang="ko-KR"/>
@@ -327,7 +387,11 @@
           </a:p>
           <a:p>
             <a:r>
-              <a:rPr lang="ko-KR" sz="1600"/>
+              <a:rPr lang="ko-KR" sz="1600">
+                <a:solidFill>
+                  <a:srgbClr val="0F172A"/>
+                </a:solidFill>
+              </a:rPr>
               <a:t>• estimation audit detail and manual-edit audit detail</a:t>
             </a:r>
             <a:endParaRPr lang="ko-KR"/>
@@ -383,7 +447,11 @@
           <a:lstStyle/>
           <a:p>
             <a:r>
-              <a:rPr lang="ko-KR" sz="2600" b="1"/>
+              <a:rPr lang="ko-KR" sz="2600" b="1">
+                <a:solidFill>
+                  <a:srgbClr val="0F172A"/>
+                </a:solidFill>
+              </a:rPr>
               <a:t>Slide 11. Replay and billing export</a:t>
             </a:r>
             <a:endParaRPr lang="ko-KR"/>
@@ -414,21 +482,33 @@
           <a:lstStyle/>
           <a:p>
             <a:r>
-              <a:rPr lang="ko-KR" sz="1700"/>
+              <a:rPr lang="ko-KR" sz="1700">
+                <a:solidFill>
+                  <a:srgbClr val="0F172A"/>
+                </a:solidFill>
+              </a:rPr>
               <a:t>• replay request create, monitor, and cancel</a:t>
             </a:r>
             <a:endParaRPr lang="ko-KR"/>
           </a:p>
           <a:p>
             <a:r>
-              <a:rPr lang="ko-KR" sz="1700"/>
+              <a:rPr lang="ko-KR" sz="1700">
+                <a:solidFill>
+                  <a:srgbClr val="0F172A"/>
+                </a:solidFill>
+              </a:rPr>
               <a:t>• billing export create, inspect, rerun, recreate, or cancel</a:t>
             </a:r>
             <a:endParaRPr lang="ko-KR"/>
           </a:p>
           <a:p>
             <a:r>
-              <a:rPr lang="ko-KR" sz="1700"/>
+              <a:rPr lang="ko-KR" sz="1700">
+                <a:solidFill>
+                  <a:srgbClr val="0F172A"/>
+                </a:solidFill>
+              </a:rPr>
               <a:t>• processing state versus failed state versus quiet state</a:t>
             </a:r>
             <a:endParaRPr lang="ko-KR"/>
@@ -463,7 +543,11 @@
           <a:lstStyle/>
           <a:p>
             <a:r>
-              <a:rPr lang="ko-KR" sz="1600"/>
+              <a:rPr lang="ko-KR" sz="1600">
+                <a:solidFill>
+                  <a:srgbClr val="0F172A"/>
+                </a:solidFill>
+              </a:rPr>
               <a:t>Screen Capture Placeholder</a:t>
             </a:r>
             <a:endParaRPr lang="ko-KR"/>
@@ -473,7 +557,11 @@
           </a:p>
           <a:p>
             <a:r>
-              <a:rPr lang="ko-KR" sz="1600"/>
+              <a:rPr lang="ko-KR" sz="1600">
+                <a:solidFill>
+                  <a:srgbClr val="0F172A"/>
+                </a:solidFill>
+              </a:rPr>
               <a:t>• replay request detail and billing export request detail</a:t>
             </a:r>
             <a:endParaRPr lang="ko-KR"/>
@@ -529,7 +617,11 @@
           <a:lstStyle/>
           <a:p>
             <a:r>
-              <a:rPr lang="ko-KR" sz="2600" b="1"/>
+              <a:rPr lang="ko-KR" sz="2600" b="1">
+                <a:solidFill>
+                  <a:srgbClr val="0F172A"/>
+                </a:solidFill>
+              </a:rPr>
               <a:t>Slide 12. Operational events and accountability</a:t>
             </a:r>
             <a:endParaRPr lang="ko-KR"/>
@@ -560,28 +652,44 @@
           <a:lstStyle/>
           <a:p>
             <a:r>
-              <a:rPr lang="ko-KR" sz="1700"/>
+              <a:rPr lang="ko-KR" sz="1700">
+                <a:solidFill>
+                  <a:srgbClr val="0F172A"/>
+                </a:solidFill>
+              </a:rPr>
               <a:t>• operational-event timeline</a:t>
             </a:r>
             <a:endParaRPr lang="ko-KR"/>
           </a:p>
           <a:p>
             <a:r>
-              <a:rPr lang="ko-KR" sz="1700"/>
+              <a:rPr lang="ko-KR" sz="1700">
+                <a:solidFill>
+                  <a:srgbClr val="0F172A"/>
+                </a:solidFill>
+              </a:rPr>
               <a:t>• action snapshot</a:t>
             </a:r>
             <a:endParaRPr lang="ko-KR"/>
           </a:p>
           <a:p>
             <a:r>
-              <a:rPr lang="ko-KR" sz="1700"/>
+              <a:rPr lang="ko-KR" sz="1700">
+                <a:solidFill>
+                  <a:srgbClr val="0F172A"/>
+                </a:solidFill>
+              </a:rPr>
               <a:t>• created actor and updated actor on admin-managed rows</a:t>
             </a:r>
             <a:endParaRPr lang="ko-KR"/>
           </a:p>
           <a:p>
             <a:r>
-              <a:rPr lang="ko-KR" sz="1700"/>
+              <a:rPr lang="ko-KR" sz="1700">
+                <a:solidFill>
+                  <a:srgbClr val="0F172A"/>
+                </a:solidFill>
+              </a:rPr>
               <a:t>• user action audit evidence meaning</a:t>
             </a:r>
             <a:endParaRPr lang="ko-KR"/>
@@ -616,7 +724,11 @@
           <a:lstStyle/>
           <a:p>
             <a:r>
-              <a:rPr lang="ko-KR" sz="1600"/>
+              <a:rPr lang="ko-KR" sz="1600">
+                <a:solidFill>
+                  <a:srgbClr val="0F172A"/>
+                </a:solidFill>
+              </a:rPr>
               <a:t>Screen Capture Placeholder</a:t>
             </a:r>
             <a:endParaRPr lang="ko-KR"/>
@@ -626,7 +738,11 @@
           </a:p>
           <a:p>
             <a:r>
-              <a:rPr lang="ko-KR" sz="1600"/>
+              <a:rPr lang="ko-KR" sz="1600">
+                <a:solidFill>
+                  <a:srgbClr val="0F172A"/>
+                </a:solidFill>
+              </a:rPr>
               <a:t>• operational-event detail plus HES or master-data actor visibility</a:t>
             </a:r>
             <a:endParaRPr lang="ko-KR"/>
@@ -682,7 +798,11 @@
           <a:lstStyle/>
           <a:p>
             <a:r>
-              <a:rPr lang="ko-KR" sz="2600" b="1"/>
+              <a:rPr lang="ko-KR" sz="2600" b="1">
+                <a:solidFill>
+                  <a:srgbClr val="0F172A"/>
+                </a:solidFill>
+              </a:rPr>
               <a:t>Slide 13. Incident quick guide</a:t>
             </a:r>
             <a:endParaRPr lang="ko-KR"/>
@@ -713,35 +833,55 @@
           <a:lstStyle/>
           <a:p>
             <a:r>
-              <a:rPr lang="ko-KR" sz="1700"/>
+              <a:rPr lang="ko-KR" sz="1700">
+                <a:solidFill>
+                  <a:srgbClr val="0F172A"/>
+                </a:solidFill>
+              </a:rPr>
               <a:t>• stale adapter</a:t>
             </a:r>
             <a:endParaRPr lang="ko-KR"/>
           </a:p>
           <a:p>
             <a:r>
-              <a:rPr lang="ko-KR" sz="1700"/>
+              <a:rPr lang="ko-KR" sz="1700">
+                <a:solidFill>
+                  <a:srgbClr val="0F172A"/>
+                </a:solidFill>
+              </a:rPr>
               <a:t>• failed replay</a:t>
             </a:r>
             <a:endParaRPr lang="ko-KR"/>
           </a:p>
           <a:p>
             <a:r>
-              <a:rPr lang="ko-KR" sz="1700"/>
+              <a:rPr lang="ko-KR" sz="1700">
+                <a:solidFill>
+                  <a:srgbClr val="0F172A"/>
+                </a:solidFill>
+              </a:rPr>
               <a:t>• failed export</a:t>
             </a:r>
             <a:endParaRPr lang="ko-KR"/>
           </a:p>
           <a:p>
             <a:r>
-              <a:rPr lang="ko-KR" sz="1700"/>
+              <a:rPr lang="ko-KR" sz="1700">
+                <a:solidFill>
+                  <a:srgbClr val="0F172A"/>
+                </a:solidFill>
+              </a:rPr>
               <a:t>• blocking VEE</a:t>
             </a:r>
             <a:endParaRPr lang="ko-KR"/>
           </a:p>
           <a:p>
             <a:r>
-              <a:rPr lang="ko-KR" sz="1700"/>
+              <a:rPr lang="ko-KR" sz="1700">
+                <a:solidFill>
+                  <a:srgbClr val="0F172A"/>
+                </a:solidFill>
+              </a:rPr>
               <a:t>• missing master data</a:t>
             </a:r>
             <a:endParaRPr lang="ko-KR"/>
@@ -776,7 +916,11 @@
           <a:lstStyle/>
           <a:p>
             <a:r>
-              <a:rPr lang="ko-KR" sz="1600"/>
+              <a:rPr lang="ko-KR" sz="1600">
+                <a:solidFill>
+                  <a:srgbClr val="0F172A"/>
+                </a:solidFill>
+              </a:rPr>
               <a:t>Screen Capture Placeholder</a:t>
             </a:r>
             <a:endParaRPr lang="ko-KR"/>
@@ -786,7 +930,11 @@
           </a:p>
           <a:p>
             <a:r>
-              <a:rPr lang="ko-KR" sz="1600"/>
+              <a:rPr lang="ko-KR" sz="1600">
+                <a:solidFill>
+                  <a:srgbClr val="0F172A"/>
+                </a:solidFill>
+              </a:rPr>
               <a:t>• two-column quick triage table</a:t>
             </a:r>
             <a:endParaRPr lang="ko-KR"/>
@@ -842,7 +990,11 @@
           <a:lstStyle/>
           <a:p>
             <a:r>
-              <a:rPr lang="ko-KR" sz="2600" b="1"/>
+              <a:rPr lang="ko-KR" sz="2600" b="1">
+                <a:solidFill>
+                  <a:srgbClr val="0F172A"/>
+                </a:solidFill>
+              </a:rPr>
               <a:t>Slide 14. Daily closing and limitations</a:t>
             </a:r>
             <a:endParaRPr lang="ko-KR"/>
@@ -873,77 +1025,121 @@
           <a:lstStyle/>
           <a:p>
             <a:r>
-              <a:rPr lang="ko-KR" sz="1700"/>
+              <a:rPr lang="ko-KR" sz="1700">
+                <a:solidFill>
+                  <a:srgbClr val="0F172A"/>
+                </a:solidFill>
+              </a:rPr>
               <a:t>• end-of-day checks</a:t>
             </a:r>
             <a:endParaRPr lang="ko-KR"/>
           </a:p>
           <a:p>
             <a:r>
-              <a:rPr lang="ko-KR" sz="1700"/>
+              <a:rPr lang="ko-KR" sz="1700">
+                <a:solidFill>
+                  <a:srgbClr val="0F172A"/>
+                </a:solidFill>
+              </a:rPr>
               <a:t>• whether to keep the local environment running</a:t>
             </a:r>
             <a:endParaRPr lang="ko-KR"/>
           </a:p>
           <a:p>
             <a:r>
-              <a:rPr lang="ko-KR" sz="1700"/>
+              <a:rPr lang="ko-KR" sz="1700">
+                <a:solidFill>
+                  <a:srgbClr val="0F172A"/>
+                </a:solidFill>
+              </a:rPr>
               <a:t>• current preproduct limitations</a:t>
             </a:r>
             <a:endParaRPr lang="ko-KR"/>
           </a:p>
           <a:p>
             <a:r>
-              <a:rPr lang="ko-KR" sz="1700"/>
+              <a:rPr lang="ko-KR" sz="1700">
+                <a:solidFill>
+                  <a:srgbClr val="0F172A"/>
+                </a:solidFill>
+              </a:rPr>
               <a:t>• escalation posture for repeated failures</a:t>
             </a:r>
             <a:endParaRPr lang="ko-KR"/>
           </a:p>
           <a:p>
             <a:r>
-              <a:rPr lang="ko-KR" sz="1700"/>
+              <a:rPr lang="ko-KR" sz="1700">
+                <a:solidFill>
+                  <a:srgbClr val="0F172A"/>
+                </a:solidFill>
+              </a:rPr>
               <a:t>## Packaging notes</a:t>
             </a:r>
             <a:endParaRPr lang="ko-KR"/>
           </a:p>
           <a:p>
             <a:r>
-              <a:rPr lang="ko-KR" sz="1700"/>
+              <a:rPr lang="ko-KR" sz="1700">
+                <a:solidFill>
+                  <a:srgbClr val="0F172A"/>
+                </a:solidFill>
+              </a:rPr>
               <a:t>For the first training deck:</a:t>
             </a:r>
             <a:endParaRPr lang="ko-KR"/>
           </a:p>
           <a:p>
             <a:r>
-              <a:rPr lang="ko-KR" sz="1700"/>
+              <a:rPr lang="ko-KR" sz="1700">
+                <a:solidFill>
+                  <a:srgbClr val="0F172A"/>
+                </a:solidFill>
+              </a:rPr>
               <a:t>• prefer Korean UI captures</a:t>
             </a:r>
             <a:endParaRPr lang="ko-KR"/>
           </a:p>
           <a:p>
             <a:r>
-              <a:rPr lang="ko-KR" sz="1700"/>
+              <a:rPr lang="ko-KR" sz="1700">
+                <a:solidFill>
+                  <a:srgbClr val="0F172A"/>
+                </a:solidFill>
+              </a:rPr>
               <a:t>• use the same account names consistently across screenshots</a:t>
             </a:r>
             <a:endParaRPr lang="ko-KR"/>
           </a:p>
           <a:p>
             <a:r>
-              <a:rPr lang="ko-KR" sz="1700"/>
+              <a:rPr lang="ko-KR" sz="1700">
+                <a:solidFill>
+                  <a:srgbClr val="0F172A"/>
+                </a:solidFill>
+              </a:rPr>
               <a:t>• mask secrets, credentials, and environment-specific identifiers</a:t>
             </a:r>
             <a:endParaRPr lang="ko-KR"/>
           </a:p>
           <a:p>
             <a:r>
-              <a:rPr lang="ko-KR" sz="1700"/>
+              <a:rPr lang="ko-KR" sz="1700">
+                <a:solidFill>
+                  <a:srgbClr val="0F172A"/>
+                </a:solidFill>
+              </a:rPr>
               <a:t>• keep one wide desktop viewport across the whole deck</a:t>
             </a:r>
             <a:endParaRPr lang="ko-KR"/>
           </a:p>
           <a:p>
             <a:r>
-              <a:rPr lang="ko-KR" sz="1700"/>
+              <a:rPr lang="ko-KR" sz="1700">
+                <a:solidFill>
+                  <a:srgbClr val="0F172A"/>
+                </a:solidFill>
+              </a:rPr>
               <a:t>• reserve space for captions that explain what the operator should look at first</a:t>
             </a:r>
             <a:endParaRPr lang="ko-KR"/>
@@ -978,7 +1174,11 @@
           <a:lstStyle/>
           <a:p>
             <a:r>
-              <a:rPr lang="ko-KR" sz="1600"/>
+              <a:rPr lang="ko-KR" sz="1600">
+                <a:solidFill>
+                  <a:srgbClr val="0F172A"/>
+                </a:solidFill>
+              </a:rPr>
               <a:t>Screen Capture Placeholder</a:t>
             </a:r>
             <a:endParaRPr lang="ko-KR"/>
@@ -988,7 +1188,11 @@
           </a:p>
           <a:p>
             <a:r>
-              <a:rPr lang="ko-KR" sz="1600"/>
+              <a:rPr lang="ko-KR" sz="1600">
+                <a:solidFill>
+                  <a:srgbClr val="0F172A"/>
+                </a:solidFill>
+              </a:rPr>
               <a:t>• closing checklist or known-limitations summary</a:t>
             </a:r>
             <a:endParaRPr lang="ko-KR"/>
@@ -1044,7 +1248,11 @@
           <a:lstStyle/>
           <a:p>
             <a:r>
-              <a:rPr lang="ko-KR" sz="2600" b="1"/>
+              <a:rPr lang="ko-KR" sz="2600" b="1">
+                <a:solidFill>
+                  <a:srgbClr val="0F172A"/>
+                </a:solidFill>
+              </a:rPr>
               <a:t>Slide 2. System at a glance</a:t>
             </a:r>
             <a:endParaRPr lang="ko-KR"/>
@@ -1075,35 +1283,55 @@
           <a:lstStyle/>
           <a:p>
             <a:r>
-              <a:rPr lang="ko-KR" sz="1700"/>
+              <a:rPr lang="ko-KR" sz="1700">
+                <a:solidFill>
+                  <a:srgbClr val="0F172A"/>
+                </a:solidFill>
+              </a:rPr>
               <a:t>• PostgreSQL</a:t>
             </a:r>
             <a:endParaRPr lang="ko-KR"/>
           </a:p>
           <a:p>
             <a:r>
-              <a:rPr lang="ko-KR" sz="1700"/>
+              <a:rPr lang="ko-KR" sz="1700">
+                <a:solidFill>
+                  <a:srgbClr val="0F172A"/>
+                </a:solidFill>
+              </a:rPr>
               <a:t>• Flask web UI</a:t>
             </a:r>
             <a:endParaRPr lang="ko-KR"/>
           </a:p>
           <a:p>
             <a:r>
-              <a:rPr lang="ko-KR" sz="1700"/>
+              <a:rPr lang="ko-KR" sz="1700">
+                <a:solidFill>
+                  <a:srgbClr val="0F172A"/>
+                </a:solidFill>
+              </a:rPr>
               <a:t>• adapter queue commands</a:t>
             </a:r>
             <a:endParaRPr lang="ko-KR"/>
           </a:p>
           <a:p>
             <a:r>
-              <a:rPr lang="ko-KR" sz="1700"/>
+              <a:rPr lang="ko-KR" sz="1700">
+                <a:solidFill>
+                  <a:srgbClr val="0F172A"/>
+                </a:solidFill>
+              </a:rPr>
               <a:t>• HES, adapter, VEE, replay, export, and operational-event as the main operator</a:t>
             </a:r>
             <a:endParaRPr lang="ko-KR"/>
           </a:p>
           <a:p>
             <a:r>
-              <a:rPr lang="ko-KR" sz="1700"/>
+              <a:rPr lang="ko-KR" sz="1700">
+                <a:solidFill>
+                  <a:srgbClr val="0F172A"/>
+                </a:solidFill>
+              </a:rPr>
               <a:t>objects</a:t>
             </a:r>
             <a:endParaRPr lang="ko-KR"/>
@@ -1138,7 +1366,11 @@
           <a:lstStyle/>
           <a:p>
             <a:r>
-              <a:rPr lang="ko-KR" sz="1600"/>
+              <a:rPr lang="ko-KR" sz="1600">
+                <a:solidFill>
+                  <a:srgbClr val="0F172A"/>
+                </a:solidFill>
+              </a:rPr>
               <a:t>Screen Capture Placeholder</a:t>
             </a:r>
             <a:endParaRPr lang="ko-KR"/>
@@ -1148,7 +1380,11 @@
           </a:p>
           <a:p>
             <a:r>
-              <a:rPr lang="ko-KR" sz="1600"/>
+              <a:rPr lang="ko-KR" sz="1600">
+                <a:solidFill>
+                  <a:srgbClr val="0F172A"/>
+                </a:solidFill>
+              </a:rPr>
               <a:t>• simple system block diagram or dashboard plus HES detail thumbnail</a:t>
             </a:r>
             <a:endParaRPr lang="ko-KR"/>
@@ -1204,7 +1440,11 @@
           <a:lstStyle/>
           <a:p>
             <a:r>
-              <a:rPr lang="ko-KR" sz="2600" b="1"/>
+              <a:rPr lang="ko-KR" sz="2600" b="1">
+                <a:solidFill>
+                  <a:srgbClr val="0F172A"/>
+                </a:solidFill>
+              </a:rPr>
               <a:t>Slide 3. Startup procedure</a:t>
             </a:r>
             <a:endParaRPr lang="ko-KR"/>
@@ -1235,42 +1475,66 @@
           <a:lstStyle/>
           <a:p>
             <a:r>
-              <a:rPr lang="ko-KR" sz="1700"/>
+              <a:rPr lang="ko-KR" sz="1700">
+                <a:solidFill>
+                  <a:srgbClr val="0F172A"/>
+                </a:solidFill>
+              </a:rPr>
               <a:t>• verify PostgreSQL</a:t>
             </a:r>
             <a:endParaRPr lang="ko-KR"/>
           </a:p>
           <a:p>
             <a:r>
-              <a:rPr lang="ko-KR" sz="1700"/>
+              <a:rPr lang="ko-KR" sz="1700">
+                <a:solidFill>
+                  <a:srgbClr val="0F172A"/>
+                </a:solidFill>
+              </a:rPr>
               <a:t>• activate environment</a:t>
             </a:r>
             <a:endParaRPr lang="ko-KR"/>
           </a:p>
           <a:p>
             <a:r>
-              <a:rPr lang="ko-KR" sz="1700"/>
+              <a:rPr lang="ko-KR" sz="1700">
+                <a:solidFill>
+                  <a:srgbClr val="0F172A"/>
+                </a:solidFill>
+              </a:rPr>
               <a:t>• first-time bootstrap commands only when needed</a:t>
             </a:r>
             <a:endParaRPr lang="ko-KR"/>
           </a:p>
           <a:p>
             <a:r>
-              <a:rPr lang="ko-KR" sz="1700"/>
+              <a:rPr lang="ko-KR" sz="1700">
+                <a:solidFill>
+                  <a:srgbClr val="0F172A"/>
+                </a:solidFill>
+              </a:rPr>
               <a:t>• start make run</a:t>
             </a:r>
             <a:endParaRPr lang="ko-KR"/>
           </a:p>
           <a:p>
             <a:r>
-              <a:rPr lang="ko-KR" sz="1700"/>
+              <a:rPr lang="ko-KR" sz="1700">
+                <a:solidFill>
+                  <a:srgbClr val="0F172A"/>
+                </a:solidFill>
+              </a:rPr>
               <a:t>• run adapter queue commands in separate shells when needed</a:t>
             </a:r>
             <a:endParaRPr lang="ko-KR"/>
           </a:p>
           <a:p>
             <a:r>
-              <a:rPr lang="ko-KR" sz="1700"/>
+              <a:rPr lang="ko-KR" sz="1700">
+                <a:solidFill>
+                  <a:srgbClr val="0F172A"/>
+                </a:solidFill>
+              </a:rPr>
               <a:t>• post-start checks</a:t>
             </a:r>
             <a:endParaRPr lang="ko-KR"/>
@@ -1305,7 +1569,11 @@
           <a:lstStyle/>
           <a:p>
             <a:r>
-              <a:rPr lang="ko-KR" sz="1600"/>
+              <a:rPr lang="ko-KR" sz="1600">
+                <a:solidFill>
+                  <a:srgbClr val="0F172A"/>
+                </a:solidFill>
+              </a:rPr>
               <a:t>Screen Capture Placeholder</a:t>
             </a:r>
             <a:endParaRPr lang="ko-KR"/>
@@ -1315,7 +1583,11 @@
           </a:p>
           <a:p>
             <a:r>
-              <a:rPr lang="ko-KR" sz="1600"/>
+              <a:rPr lang="ko-KR" sz="1600">
+                <a:solidFill>
+                  <a:srgbClr val="0F172A"/>
+                </a:solidFill>
+              </a:rPr>
               <a:t>• terminal command snapshot plus login or health endpoint capture</a:t>
             </a:r>
             <a:endParaRPr lang="ko-KR"/>
@@ -1371,7 +1643,11 @@
           <a:lstStyle/>
           <a:p>
             <a:r>
-              <a:rPr lang="ko-KR" sz="2600" b="1"/>
+              <a:rPr lang="ko-KR" sz="2600" b="1">
+                <a:solidFill>
+                  <a:srgbClr val="0F172A"/>
+                </a:solidFill>
+              </a:rPr>
               <a:t>Slide 4. Shutdown procedure</a:t>
             </a:r>
             <a:endParaRPr lang="ko-KR"/>
@@ -1402,35 +1678,55 @@
           <a:lstStyle/>
           <a:p>
             <a:r>
-              <a:rPr lang="ko-KR" sz="1700"/>
+              <a:rPr lang="ko-KR" sz="1700">
+                <a:solidFill>
+                  <a:srgbClr val="0F172A"/>
+                </a:solidFill>
+              </a:rPr>
               <a:t>• check in-flight replay, export, and adapter work</a:t>
             </a:r>
             <a:endParaRPr lang="ko-KR"/>
           </a:p>
           <a:p>
             <a:r>
-              <a:rPr lang="ko-KR" sz="1700"/>
+              <a:rPr lang="ko-KR" sz="1700">
+                <a:solidFill>
+                  <a:srgbClr val="0F172A"/>
+                </a:solidFill>
+              </a:rPr>
               <a:t>• stop worker shells first</a:t>
             </a:r>
             <a:endParaRPr lang="ko-KR"/>
           </a:p>
           <a:p>
             <a:r>
-              <a:rPr lang="ko-KR" sz="1700"/>
+              <a:rPr lang="ko-KR" sz="1700">
+                <a:solidFill>
+                  <a:srgbClr val="0F172A"/>
+                </a:solidFill>
+              </a:rPr>
               <a:t>• stop Flask</a:t>
             </a:r>
             <a:endParaRPr lang="ko-KR"/>
           </a:p>
           <a:p>
             <a:r>
-              <a:rPr lang="ko-KR" sz="1700"/>
+              <a:rPr lang="ko-KR" sz="1700">
+                <a:solidFill>
+                  <a:srgbClr val="0F172A"/>
+                </a:solidFill>
+              </a:rPr>
               <a:t>• stop PostgreSQL only when appropriate</a:t>
             </a:r>
             <a:endParaRPr lang="ko-KR"/>
           </a:p>
           <a:p>
             <a:r>
-              <a:rPr lang="ko-KR" sz="1700"/>
+              <a:rPr lang="ko-KR" sz="1700">
+                <a:solidFill>
+                  <a:srgbClr val="0F172A"/>
+                </a:solidFill>
+              </a:rPr>
               <a:t>• restart after abnormal stop</a:t>
             </a:r>
             <a:endParaRPr lang="ko-KR"/>
@@ -1465,7 +1761,11 @@
           <a:lstStyle/>
           <a:p>
             <a:r>
-              <a:rPr lang="ko-KR" sz="1600"/>
+              <a:rPr lang="ko-KR" sz="1600">
+                <a:solidFill>
+                  <a:srgbClr val="0F172A"/>
+                </a:solidFill>
+              </a:rPr>
               <a:t>Screen Capture Placeholder</a:t>
             </a:r>
             <a:endParaRPr lang="ko-KR"/>
@@ -1475,7 +1775,11 @@
           </a:p>
           <a:p>
             <a:r>
-              <a:rPr lang="ko-KR" sz="1600"/>
+              <a:rPr lang="ko-KR" sz="1600">
+                <a:solidFill>
+                  <a:srgbClr val="0F172A"/>
+                </a:solidFill>
+              </a:rPr>
               <a:t>• detail page showing processing state or a simple checklist panel</a:t>
             </a:r>
             <a:endParaRPr lang="ko-KR"/>
@@ -1531,7 +1835,11 @@
           <a:lstStyle/>
           <a:p>
             <a:r>
-              <a:rPr lang="ko-KR" sz="2600" b="1"/>
+              <a:rPr lang="ko-KR" sz="2600" b="1">
+                <a:solidFill>
+                  <a:srgbClr val="0F172A"/>
+                </a:solidFill>
+              </a:rPr>
               <a:t>Slide 5. Daily opening checklist</a:t>
             </a:r>
             <a:endParaRPr lang="ko-KR"/>
@@ -1562,35 +1870,55 @@
           <a:lstStyle/>
           <a:p>
             <a:r>
-              <a:rPr lang="ko-KR" sz="1700"/>
+              <a:rPr lang="ko-KR" sz="1700">
+                <a:solidFill>
+                  <a:srgbClr val="0F172A"/>
+                </a:solidFill>
+              </a:rPr>
               <a:t>• log in</a:t>
             </a:r>
             <a:endParaRPr lang="ko-KR"/>
           </a:p>
           <a:p>
             <a:r>
-              <a:rPr lang="ko-KR" sz="1700"/>
+              <a:rPr lang="ko-KR" sz="1700">
+                <a:solidFill>
+                  <a:srgbClr val="0F172A"/>
+                </a:solidFill>
+              </a:rPr>
               <a:t>• open dashboard</a:t>
             </a:r>
             <a:endParaRPr lang="ko-KR"/>
           </a:p>
           <a:p>
             <a:r>
-              <a:rPr lang="ko-KR" sz="1700"/>
+              <a:rPr lang="ko-KR" sz="1700">
+                <a:solidFill>
+                  <a:srgbClr val="0F172A"/>
+                </a:solidFill>
+              </a:rPr>
               <a:t>• review open alerts</a:t>
             </a:r>
             <a:endParaRPr lang="ko-KR"/>
           </a:p>
           <a:p>
             <a:r>
-              <a:rPr lang="ko-KR" sz="1700"/>
+              <a:rPr lang="ko-KR" sz="1700">
+                <a:solidFill>
+                  <a:srgbClr val="0F172A"/>
+                </a:solidFill>
+              </a:rPr>
               <a:t>• review recent operational events</a:t>
             </a:r>
             <a:endParaRPr lang="ko-KR"/>
           </a:p>
           <a:p>
             <a:r>
-              <a:rPr lang="ko-KR" sz="1700"/>
+              <a:rPr lang="ko-KR" sz="1700">
+                <a:solidFill>
+                  <a:srgbClr val="0F172A"/>
+                </a:solidFill>
+              </a:rPr>
               <a:t>• identify stale adapters, failed replay, failed export, or blocking VEE</a:t>
             </a:r>
             <a:endParaRPr lang="ko-KR"/>
@@ -1625,7 +1953,11 @@
           <a:lstStyle/>
           <a:p>
             <a:r>
-              <a:rPr lang="ko-KR" sz="1600"/>
+              <a:rPr lang="ko-KR" sz="1600">
+                <a:solidFill>
+                  <a:srgbClr val="0F172A"/>
+                </a:solidFill>
+              </a:rPr>
               <a:t>Screen Capture Placeholder</a:t>
             </a:r>
             <a:endParaRPr lang="ko-KR"/>
@@ -1635,7 +1967,11 @@
           </a:p>
           <a:p>
             <a:r>
-              <a:rPr lang="ko-KR" sz="1600"/>
+              <a:rPr lang="ko-KR" sz="1600">
+                <a:solidFill>
+                  <a:srgbClr val="0F172A"/>
+                </a:solidFill>
+              </a:rPr>
               <a:t>• dashboard with alert and event sections visible</a:t>
             </a:r>
             <a:endParaRPr lang="ko-KR"/>
@@ -1691,7 +2027,11 @@
           <a:lstStyle/>
           <a:p>
             <a:r>
-              <a:rPr lang="ko-KR" sz="2600" b="1"/>
+              <a:rPr lang="ko-KR" sz="2600" b="1">
+                <a:solidFill>
+                  <a:srgbClr val="0F172A"/>
+                </a:solidFill>
+              </a:rPr>
               <a:t>Slide 6. HES and adapter operations</a:t>
             </a:r>
             <a:endParaRPr lang="ko-KR"/>
@@ -1722,28 +2062,44 @@
           <a:lstStyle/>
           <a:p>
             <a:r>
-              <a:rPr lang="ko-KR" sz="1700"/>
+              <a:rPr lang="ko-KR" sz="1700">
+                <a:solidFill>
+                  <a:srgbClr val="0F172A"/>
+                </a:solidFill>
+              </a:rPr>
               <a:t>• HES list and detail</a:t>
             </a:r>
             <a:endParaRPr lang="ko-KR"/>
           </a:p>
           <a:p>
             <a:r>
-              <a:rPr lang="ko-KR" sz="1700"/>
+              <a:rPr lang="ko-KR" sz="1700">
+                <a:solidFill>
+                  <a:srgbClr val="0F172A"/>
+                </a:solidFill>
+              </a:rPr>
               <a:t>• adapter list and detail</a:t>
             </a:r>
             <a:endParaRPr lang="ko-KR"/>
           </a:p>
           <a:p>
             <a:r>
-              <a:rPr lang="ko-KR" sz="1700"/>
+              <a:rPr lang="ko-KR" sz="1700">
+                <a:solidFill>
+                  <a:srgbClr val="0F172A"/>
+                </a:solidFill>
+              </a:rPr>
               <a:t>• Enable, Pause, Run Once</a:t>
             </a:r>
             <a:endParaRPr lang="ko-KR"/>
           </a:p>
           <a:p>
             <a:r>
-              <a:rPr lang="ko-KR" sz="1700"/>
+              <a:rPr lang="ko-KR" sz="1700">
+                <a:solidFill>
+                  <a:srgbClr val="0F172A"/>
+                </a:solidFill>
+              </a:rPr>
               <a:t>• runtime versus human actor interpretation</a:t>
             </a:r>
             <a:endParaRPr lang="ko-KR"/>
@@ -1778,7 +2134,11 @@
           <a:lstStyle/>
           <a:p>
             <a:r>
-              <a:rPr lang="ko-KR" sz="1600"/>
+              <a:rPr lang="ko-KR" sz="1600">
+                <a:solidFill>
+                  <a:srgbClr val="0F172A"/>
+                </a:solidFill>
+              </a:rPr>
               <a:t>Screen Capture Placeholder</a:t>
             </a:r>
             <a:endParaRPr lang="ko-KR"/>
@@ -1788,7 +2148,11 @@
           </a:p>
           <a:p>
             <a:r>
-              <a:rPr lang="ko-KR" sz="1600"/>
+              <a:rPr lang="ko-KR" sz="1600">
+                <a:solidFill>
+                  <a:srgbClr val="0F172A"/>
+                </a:solidFill>
+              </a:rPr>
               <a:t>• HES detail and adapter detail</a:t>
             </a:r>
             <a:endParaRPr lang="ko-KR"/>
@@ -1844,7 +2208,11 @@
           <a:lstStyle/>
           <a:p>
             <a:r>
-              <a:rPr lang="ko-KR" sz="2600" b="1"/>
+              <a:rPr lang="ko-KR" sz="2600" b="1">
+                <a:solidFill>
+                  <a:srgbClr val="0F172A"/>
+                </a:solidFill>
+              </a:rPr>
               <a:t>Slide 7. Master data minimum</a:t>
             </a:r>
             <a:endParaRPr lang="ko-KR"/>
@@ -1875,35 +2243,55 @@
           <a:lstStyle/>
           <a:p>
             <a:r>
-              <a:rPr lang="ko-KR" sz="1700"/>
+              <a:rPr lang="ko-KR" sz="1700">
+                <a:solidFill>
+                  <a:srgbClr val="0F172A"/>
+                </a:solidFill>
+              </a:rPr>
               <a:t>• service point</a:t>
             </a:r>
             <a:endParaRPr lang="ko-KR"/>
           </a:p>
           <a:p>
             <a:r>
-              <a:rPr lang="ko-KR" sz="1700"/>
+              <a:rPr lang="ko-KR" sz="1700">
+                <a:solidFill>
+                  <a:srgbClr val="0F172A"/>
+                </a:solidFill>
+              </a:rPr>
               <a:t>• device</a:t>
             </a:r>
             <a:endParaRPr lang="ko-KR"/>
           </a:p>
           <a:p>
             <a:r>
-              <a:rPr lang="ko-KR" sz="1700"/>
+              <a:rPr lang="ko-KR" sz="1700">
+                <a:solidFill>
+                  <a:srgbClr val="0F172A"/>
+                </a:solidFill>
+              </a:rPr>
               <a:t>• measuring component</a:t>
             </a:r>
             <a:endParaRPr lang="ko-KR"/>
           </a:p>
           <a:p>
             <a:r>
-              <a:rPr lang="ko-KR" sz="1700"/>
+              <a:rPr lang="ko-KR" sz="1700">
+                <a:solidFill>
+                  <a:srgbClr val="0F172A"/>
+                </a:solidFill>
+              </a:rPr>
               <a:t>• installation history</a:t>
             </a:r>
             <a:endParaRPr lang="ko-KR"/>
           </a:p>
           <a:p>
             <a:r>
-              <a:rPr lang="ko-KR" sz="1700"/>
+              <a:rPr lang="ko-KR" sz="1700">
+                <a:solidFill>
+                  <a:srgbClr val="0F172A"/>
+                </a:solidFill>
+              </a:rPr>
               <a:t>• why mapping fails when these are missing</a:t>
             </a:r>
             <a:endParaRPr lang="ko-KR"/>
@@ -1938,7 +2326,11 @@
           <a:lstStyle/>
           <a:p>
             <a:r>
-              <a:rPr lang="ko-KR" sz="1600"/>
+              <a:rPr lang="ko-KR" sz="1600">
+                <a:solidFill>
+                  <a:srgbClr val="0F172A"/>
+                </a:solidFill>
+              </a:rPr>
               <a:t>Screen Capture Placeholder</a:t>
             </a:r>
             <a:endParaRPr lang="ko-KR"/>
@@ -1948,7 +2340,11 @@
           </a:p>
           <a:p>
             <a:r>
-              <a:rPr lang="ko-KR" sz="1600"/>
+              <a:rPr lang="ko-KR" sz="1600">
+                <a:solidFill>
+                  <a:srgbClr val="0F172A"/>
+                </a:solidFill>
+              </a:rPr>
               <a:t>• master-data page with actor visibility and empty-state guidance</a:t>
             </a:r>
             <a:endParaRPr lang="ko-KR"/>
@@ -2004,7 +2400,11 @@
           <a:lstStyle/>
           <a:p>
             <a:r>
-              <a:rPr lang="ko-KR" sz="2600" b="1"/>
+              <a:rPr lang="ko-KR" sz="2600" b="1">
+                <a:solidFill>
+                  <a:srgbClr val="0F172A"/>
+                </a:solidFill>
+              </a:rPr>
               <a:t>Slide 8. Raw, canonical, and final lineage</a:t>
             </a:r>
             <a:endParaRPr lang="ko-KR"/>
@@ -2035,28 +2435,44 @@
           <a:lstStyle/>
           <a:p>
             <a:r>
-              <a:rPr lang="ko-KR" sz="1700"/>
+              <a:rPr lang="ko-KR" sz="1700">
+                <a:solidFill>
+                  <a:srgbClr val="0F172A"/>
+                </a:solidFill>
+              </a:rPr>
               <a:t>• review raw reads and raw events first</a:t>
             </a:r>
             <a:endParaRPr lang="ko-KR"/>
           </a:p>
           <a:p>
             <a:r>
-              <a:rPr lang="ko-KR" sz="1700"/>
+              <a:rPr lang="ko-KR" sz="1700">
+                <a:solidFill>
+                  <a:srgbClr val="0F172A"/>
+                </a:solidFill>
+              </a:rPr>
               <a:t>• confirm canonical progression</a:t>
             </a:r>
             <a:endParaRPr lang="ko-KR"/>
           </a:p>
           <a:p>
             <a:r>
-              <a:rPr lang="ko-KR" sz="1700"/>
+              <a:rPr lang="ko-KR" sz="1700">
+                <a:solidFill>
+                  <a:srgbClr val="0F172A"/>
+                </a:solidFill>
+              </a:rPr>
               <a:t>• confirm final authoritative state</a:t>
             </a:r>
             <a:endParaRPr lang="ko-KR"/>
           </a:p>
           <a:p>
             <a:r>
-              <a:rPr lang="ko-KR" sz="1700"/>
+              <a:rPr lang="ko-KR" sz="1700">
+                <a:solidFill>
+                  <a:srgbClr val="0F172A"/>
+                </a:solidFill>
+              </a:rPr>
               <a:t>• use lineage screens to trace one sample end to end</a:t>
             </a:r>
             <a:endParaRPr lang="ko-KR"/>
@@ -2091,7 +2507,11 @@
           <a:lstStyle/>
           <a:p>
             <a:r>
-              <a:rPr lang="ko-KR" sz="1600"/>
+              <a:rPr lang="ko-KR" sz="1600">
+                <a:solidFill>
+                  <a:srgbClr val="0F172A"/>
+                </a:solidFill>
+              </a:rPr>
               <a:t>Screen Capture Placeholder</a:t>
             </a:r>
             <a:endParaRPr lang="ko-KR"/>
@@ -2101,7 +2521,11 @@
           </a:p>
           <a:p>
             <a:r>
-              <a:rPr lang="ko-KR" sz="1600"/>
+              <a:rPr lang="ko-KR" sz="1600">
+                <a:solidFill>
+                  <a:srgbClr val="0F172A"/>
+                </a:solidFill>
+              </a:rPr>
               <a:t>• canonical or final measurement detail/list capture</a:t>
             </a:r>
             <a:endParaRPr lang="ko-KR"/>
@@ -2157,7 +2581,11 @@
           <a:lstStyle/>
           <a:p>
             <a:r>
-              <a:rPr lang="ko-KR" sz="2600" b="1"/>
+              <a:rPr lang="ko-KR" sz="2600" b="1">
+                <a:solidFill>
+                  <a:srgbClr val="0F172A"/>
+                </a:solidFill>
+              </a:rPr>
               <a:t>Slide 9. VEE exception triage</a:t>
             </a:r>
             <a:endParaRPr lang="ko-KR"/>
@@ -2188,28 +2616,44 @@
           <a:lstStyle/>
           <a:p>
             <a:r>
-              <a:rPr lang="ko-KR" sz="1700"/>
+              <a:rPr lang="ko-KR" sz="1700">
+                <a:solidFill>
+                  <a:srgbClr val="0F172A"/>
+                </a:solidFill>
+              </a:rPr>
               <a:t>• start from the queue</a:t>
             </a:r>
             <a:endParaRPr lang="ko-KR"/>
           </a:p>
           <a:p>
             <a:r>
-              <a:rPr lang="ko-KR" sz="1700"/>
+              <a:rPr lang="ko-KR" sz="1700">
+                <a:solidFill>
+                  <a:srgbClr val="0F172A"/>
+                </a:solidFill>
+              </a:rPr>
               <a:t>• prioritize blocking items</a:t>
             </a:r>
             <a:endParaRPr lang="ko-KR"/>
           </a:p>
           <a:p>
             <a:r>
-              <a:rPr lang="ko-KR" sz="1700"/>
+              <a:rPr lang="ko-KR" sz="1700">
+                <a:solidFill>
+                  <a:srgbClr val="0F172A"/>
+                </a:solidFill>
+              </a:rPr>
               <a:t>• use detail view for blocked reason, event context, and next action</a:t>
             </a:r>
             <a:endParaRPr lang="ko-KR"/>
           </a:p>
           <a:p>
             <a:r>
-              <a:rPr lang="ko-KR" sz="1700"/>
+              <a:rPr lang="ko-KR" sz="1700">
+                <a:solidFill>
+                  <a:srgbClr val="0F172A"/>
+                </a:solidFill>
+              </a:rPr>
               <a:t>• understand re-evaluate versus correction</a:t>
             </a:r>
             <a:endParaRPr lang="ko-KR"/>
@@ -2244,7 +2688,11 @@
           <a:lstStyle/>
           <a:p>
             <a:r>
-              <a:rPr lang="ko-KR" sz="1600"/>
+              <a:rPr lang="ko-KR" sz="1600">
+                <a:solidFill>
+                  <a:srgbClr val="0F172A"/>
+                </a:solidFill>
+              </a:rPr>
               <a:t>Screen Capture Placeholder</a:t>
             </a:r>
             <a:endParaRPr lang="ko-KR"/>
@@ -2254,7 +2702,11 @@
           </a:p>
           <a:p>
             <a:r>
-              <a:rPr lang="ko-KR" sz="1600"/>
+              <a:rPr lang="ko-KR" sz="1600">
+                <a:solidFill>
+                  <a:srgbClr val="0F172A"/>
+                </a:solidFill>
+              </a:rPr>
               <a:t>• VEE exception queue and detail</a:t>
             </a:r>
             <a:endParaRPr lang="ko-KR"/>

</xml_diff>